<commit_message>
Update ERA participant pack and add Python starter and briefing PDF
</commit_message>
<xml_diff>
--- a/slides/ERA-Hackathon-Data-Briefing.pptx
+++ b/slides/ERA-Hackathon-Data-Briefing.pptx
@@ -2,20 +2,20 @@
 <file path=ppt/presentation.xml><?xml version="1.0" encoding="utf-8"?>
 <p:presentation xmlns:p="http://schemas.openxmlformats.org/presentationml/2006/main">
   <p:sldMasterIdLst>
-    <p:sldMasterId xmlns:r="http://schemas.openxmlformats.org/officeDocument/2006/relationships" id="2147483648" r:id="Ra5f3fcb3c86049c9"/>
+    <p:sldMasterId xmlns:r="http://schemas.openxmlformats.org/officeDocument/2006/relationships" id="2147483648" r:id="Ra2f211f037b54840"/>
   </p:sldMasterIdLst>
   <p:notesMasterIdLst>
-    <p:notesMasterId xmlns:r="http://schemas.openxmlformats.org/officeDocument/2006/relationships" r:id="R55bd42a6318a4472"/>
+    <p:notesMasterId xmlns:r="http://schemas.openxmlformats.org/officeDocument/2006/relationships" r:id="R7ff7a5d711d34605"/>
   </p:notesMasterIdLst>
   <p:sldIdLst>
-    <p:sldId xmlns:r="http://schemas.openxmlformats.org/officeDocument/2006/relationships" id="256" r:id="R89c0ec1784664d73"/>
-    <p:sldId xmlns:r="http://schemas.openxmlformats.org/officeDocument/2006/relationships" id="257" r:id="Rd21a7d6bd88341f8"/>
-    <p:sldId xmlns:r="http://schemas.openxmlformats.org/officeDocument/2006/relationships" id="258" r:id="R996f5f4ab5614b38"/>
-    <p:sldId xmlns:r="http://schemas.openxmlformats.org/officeDocument/2006/relationships" id="259" r:id="R0944e053a0f8418d"/>
-    <p:sldId xmlns:r="http://schemas.openxmlformats.org/officeDocument/2006/relationships" id="260" r:id="R402a5427f60445de"/>
-    <p:sldId xmlns:r="http://schemas.openxmlformats.org/officeDocument/2006/relationships" id="261" r:id="R469b9a658d3347f9"/>
-    <p:sldId xmlns:r="http://schemas.openxmlformats.org/officeDocument/2006/relationships" id="262" r:id="Ra43df729861e43d9"/>
-    <p:sldId xmlns:r="http://schemas.openxmlformats.org/officeDocument/2006/relationships" id="263" r:id="R3c3582aeaeb9402a"/>
+    <p:sldId xmlns:r="http://schemas.openxmlformats.org/officeDocument/2006/relationships" id="256" r:id="Rcec712fde5ce47de"/>
+    <p:sldId xmlns:r="http://schemas.openxmlformats.org/officeDocument/2006/relationships" id="257" r:id="R261f2376f1414690"/>
+    <p:sldId xmlns:r="http://schemas.openxmlformats.org/officeDocument/2006/relationships" id="258" r:id="R7fdeaa85cfc347ba"/>
+    <p:sldId xmlns:r="http://schemas.openxmlformats.org/officeDocument/2006/relationships" id="259" r:id="R4b36799e3cfc4a5a"/>
+    <p:sldId xmlns:r="http://schemas.openxmlformats.org/officeDocument/2006/relationships" id="260" r:id="R34cbdbbb5eee42fd"/>
+    <p:sldId xmlns:r="http://schemas.openxmlformats.org/officeDocument/2006/relationships" id="261" r:id="R3d51474b15574a0a"/>
+    <p:sldId xmlns:r="http://schemas.openxmlformats.org/officeDocument/2006/relationships" id="262" r:id="R8ea61ce599c14768"/>
+    <p:sldId xmlns:r="http://schemas.openxmlformats.org/officeDocument/2006/relationships" id="263" r:id="R1eb565ca0be440d9"/>
   </p:sldIdLst>
   <p:sldSz cx="12192000" cy="6858000"/>
   <p:notesSz cx="6858000" cy="9144000"/>
@@ -805,25 +805,7 @@
           <a:lstStyle xmlns:a="http://schemas.openxmlformats.org/drawingml/2006/main"/>
           <a:p xmlns:a="http://schemas.openxmlformats.org/drawingml/2006/main">
             <a:r>
-              <a:t>[Sources]</a:t>
-            </a:r>
-            <a:endParaRPr/>
-          </a:p>
-          <a:p xmlns:a="http://schemas.openxmlformats.org/drawingml/2006/main">
-            <a:r>
-              <a:t>- ../TASK.md</a:t>
-            </a:r>
-            <a:endParaRPr/>
-          </a:p>
-          <a:p xmlns:a="http://schemas.openxmlformats.org/drawingml/2006/main">
-            <a:r>
-              <a:t>- ../data/data_dictionary.md</a:t>
-            </a:r>
-            <a:endParaRPr/>
-          </a:p>
-          <a:p xmlns:a="http://schemas.openxmlformats.org/drawingml/2006/main">
-            <a:r>
-              <a:t>[/Sources]</a:t>
+              <a:t>VS Plotter by Rafael Arvelo, extension ID RafaelArvelo.vsplotter. Instructions: https://marketplace.visualstudio.com/items?itemName=RafaelArvelo.vsplotter. Open a CSV, run VSPlotter: Create Plot from file, choose DateTime for X and the three power columns for Y.</a:t>
             </a:r>
             <a:endParaRPr/>
           </a:p>
@@ -1072,25 +1054,7 @@
           <a:lstStyle xmlns:a="http://schemas.openxmlformats.org/drawingml/2006/main"/>
           <a:p xmlns:a="http://schemas.openxmlformats.org/drawingml/2006/main">
             <a:r>
-              <a:t>[Sources]</a:t>
-            </a:r>
-            <a:endParaRPr/>
-          </a:p>
-          <a:p xmlns:a="http://schemas.openxmlformats.org/drawingml/2006/main">
-            <a:r>
-              <a:t>- ../TASK.md</a:t>
-            </a:r>
-            <a:endParaRPr/>
-          </a:p>
-          <a:p xmlns:a="http://schemas.openxmlformats.org/drawingml/2006/main">
-            <a:r>
-              <a:t>- ../data/data_dictionary.md</a:t>
-            </a:r>
-            <a:endParaRPr/>
-          </a:p>
-          <a:p xmlns:a="http://schemas.openxmlformats.org/drawingml/2006/main">
-            <a:r>
-              <a:t>[/Sources]</a:t>
+              <a:t>If you share work from this event or continue using the data afterwards, acknowledge the SEND team at Keele University and cite both the data repository and the associated paper. The paper is a submitted manuscript under review. See ACKNOWLEDGEMENTS.md for the full citation and wording you can adapt.</a:t>
             </a:r>
             <a:endParaRPr/>
           </a:p>
@@ -1159,7 +1123,7 @@
   </p:cSld>
   <p:clrMap bg1="lt1" tx1="dk1" bg2="lt2" tx2="dk2" accent1="accent1" accent2="accent2" accent3="accent3" accent4="accent4" accent5="accent5" accent6="accent6" hlink="hlink" folHlink="folHlink"/>
   <p:sldLayoutIdLst>
-    <p:sldLayoutId xmlns:r="http://schemas.openxmlformats.org/officeDocument/2006/relationships" id="2147483649" r:id="R3edf2b5060f74ce4"/>
+    <p:sldLayoutId xmlns:r="http://schemas.openxmlformats.org/officeDocument/2006/relationships" id="2147483649" r:id="R0ceed60928ec42d7"/>
   </p:sldLayoutIdLst>
   <p:txStyles>
     <p:titleStyle>
@@ -1841,6 +1805,110 @@
           </a:p>
         </p:txBody>
       </p:sp>
+      <p:sp>
+        <p:nvSpPr>
+          <p:cNvPr id="5" name="repository-link">
+            <a:extLst xmlns:a="http://schemas.openxmlformats.org/drawingml/2006/main">
+              <a:ext uri="{FF2B5EF4-FFF2-40B4-BE49-F238E27FC236}">
+                <a16:creationId xmlns:a16="http://schemas.microsoft.com/office/drawing/2014/main" id="{AAA68470-EF1B-4DDB-A7BE-23E80383D651}"/>
+              </a:ext>
+            </a:extLst>
+          </p:cNvPr>
+          <p:cNvSpPr>
+            <a:spLocks xmlns:a="http://schemas.openxmlformats.org/drawingml/2006/main" noGrp="1"/>
+          </p:cNvSpPr>
+          <p:nvPr/>
+        </p:nvSpPr>
+        <p:spPr>
+          <a:xfrm xmlns:a="http://schemas.openxmlformats.org/drawingml/2006/main">
+            <a:off x="400050" y="5410200"/>
+            <a:ext cx="11391900" cy="457200"/>
+          </a:xfrm>
+          <a:prstGeom xmlns:a="http://schemas.openxmlformats.org/drawingml/2006/main" prst="rect">
+            <a:avLst/>
+          </a:prstGeom>
+          <a:noFill xmlns:a="http://schemas.openxmlformats.org/drawingml/2006/main"/>
+          <a:ln xmlns:a="http://schemas.openxmlformats.org/drawingml/2006/main" w="0">
+            <a:noFill/>
+          </a:ln>
+        </p:spPr>
+        <p:txBody>
+          <a:bodyPr xmlns:a="http://schemas.openxmlformats.org/drawingml/2006/main">
+            <a:noAutofit/>
+          </a:bodyPr>
+          <a:lstStyle xmlns:a="http://schemas.openxmlformats.org/drawingml/2006/main"/>
+          <a:p xmlns:a="http://schemas.openxmlformats.org/drawingml/2006/main">
+            <a:pPr>
+              <a:buNone/>
+              <a:defRPr sz="2400" b="1">
+                <a:solidFill>
+                  <a:srgbClr val="000000"/>
+                </a:solidFill>
+              </a:defRPr>
+            </a:pPr>
+            <a:r>
+              <a:rPr sz="2400" b="1">
+                <a:solidFill>
+                  <a:srgbClr val="000000"/>
+                </a:solidFill>
+              </a:rPr>
+              <a:t>github.com/SENDatKeele/ERA-event</a:t>
+            </a:r>
+          </a:p>
+        </p:txBody>
+      </p:sp>
+      <p:sp>
+        <p:nvSpPr>
+          <p:cNvPr id="6" name="repository-guide">
+            <a:extLst xmlns:a="http://schemas.openxmlformats.org/drawingml/2006/main">
+              <a:ext uri="{FF2B5EF4-FFF2-40B4-BE49-F238E27FC236}">
+                <a16:creationId xmlns:a16="http://schemas.microsoft.com/office/drawing/2014/main" id="{AC98427C-1E43-4746-8BFC-AC788903C767}"/>
+              </a:ext>
+            </a:extLst>
+          </p:cNvPr>
+          <p:cNvSpPr>
+            <a:spLocks xmlns:a="http://schemas.openxmlformats.org/drawingml/2006/main" noGrp="1"/>
+          </p:cNvSpPr>
+          <p:nvPr/>
+        </p:nvSpPr>
+        <p:spPr>
+          <a:xfrm xmlns:a="http://schemas.openxmlformats.org/drawingml/2006/main">
+            <a:off x="400050" y="5972175"/>
+            <a:ext cx="11391900" cy="457200"/>
+          </a:xfrm>
+          <a:prstGeom xmlns:a="http://schemas.openxmlformats.org/drawingml/2006/main" prst="rect">
+            <a:avLst/>
+          </a:prstGeom>
+          <a:noFill xmlns:a="http://schemas.openxmlformats.org/drawingml/2006/main"/>
+          <a:ln xmlns:a="http://schemas.openxmlformats.org/drawingml/2006/main" w="0">
+            <a:noFill/>
+          </a:ln>
+        </p:spPr>
+        <p:txBody>
+          <a:bodyPr xmlns:a="http://schemas.openxmlformats.org/drawingml/2006/main">
+            <a:noAutofit/>
+          </a:bodyPr>
+          <a:lstStyle xmlns:a="http://schemas.openxmlformats.org/drawingml/2006/main"/>
+          <a:p xmlns:a="http://schemas.openxmlformats.org/drawingml/2006/main">
+            <a:pPr>
+              <a:buNone/>
+              <a:defRPr sz="1725" b="0">
+                <a:solidFill>
+                  <a:srgbClr val="000000"/>
+                </a:solidFill>
+              </a:defRPr>
+            </a:pPr>
+            <a:r>
+              <a:rPr sz="1725" b="0">
+                <a:solidFill>
+                  <a:srgbClr val="000000"/>
+                </a:solidFill>
+              </a:rPr>
+              <a:t>Start with README.md and TASK.md. CSV files and the data dictionary are in data/.</a:t>
+            </a:r>
+          </a:p>
+        </p:txBody>
+      </p:sp>
     </p:spTree>
     <p:extLst>
       <p:ext uri="{BB962C8B-B14F-4D97-AF65-F5344CB8AC3E}">
@@ -3188,7 +3256,7 @@
               </a:defRPr>
             </a:pPr>
             <a:r>
-              <a:t>Use the visual plotting extension. You do not need to write code.</a:t>
+              <a:t>Use VS Plotter by Rafael Arvelo. No coding needed. Steps are in TASK.md.</a:t>
             </a:r>
           </a:p>
         </p:txBody>
@@ -3914,7 +3982,7 @@
               </a:defRPr>
             </a:pPr>
             <a:r>
-              <a:t>Four minutes to present, followed by one minute for a question.</a:t>
+              <a:t>One slide, about one minute. Focus on one finding.</a:t>
             </a:r>
           </a:p>
         </p:txBody>
@@ -4014,7 +4082,7 @@
                             <a:srgbClr val="000000"/>
                           </a:solidFill>
                         </a:rPr>
-                        <a:t>One numerical finding</a:t>
+                        <a:t>One key finding or question from the data</a:t>
                       </a:r>
                     </a:p>
                   </a:txBody>
@@ -4058,7 +4126,7 @@
                             <a:srgbClr val="000000"/>
                           </a:solidFill>
                         </a:rPr>
-                        <a:t>Why the finding matters for Keele</a:t>
+                        <a:t>Why it matters or how it could be used</a:t>
                       </a:r>
                     </a:p>
                   </a:txBody>
@@ -4102,7 +4170,7 @@
                             <a:srgbClr val="000000"/>
                           </a:solidFill>
                         </a:rPr>
-                        <a:t>One limitation, plus what your group found useful or difficult</a:t>
+                        <a:t>Any assumption or limitation needed to understand the finding</a:t>
                       </a:r>
                     </a:p>
                   </a:txBody>
@@ -4278,6 +4346,109 @@
             </a:pPr>
             <a:r>
               <a:t>Show the finding, its limits and the next check.</a:t>
+            </a:r>
+          </a:p>
+        </p:txBody>
+      </p:sp>
+      <p:sp>
+        <p:nvSpPr>
+          <p:cNvPr id="4" name="sharing-acknowledgement">
+            <a:extLst xmlns:a="http://schemas.openxmlformats.org/drawingml/2006/main">
+              <a:ext uri="{FF2B5EF4-FFF2-40B4-BE49-F238E27FC236}">
+                <a16:creationId xmlns:a16="http://schemas.microsoft.com/office/drawing/2014/main" id="{697D512D-843E-4437-81FD-E310728D03AE}"/>
+              </a:ext>
+            </a:extLst>
+          </p:cNvPr>
+          <p:cNvSpPr>
+            <a:spLocks xmlns:a="http://schemas.openxmlformats.org/drawingml/2006/main" noGrp="1"/>
+          </p:cNvSpPr>
+          <p:nvPr/>
+        </p:nvSpPr>
+        <p:spPr>
+          <a:xfrm xmlns:a="http://schemas.openxmlformats.org/drawingml/2006/main">
+            <a:off x="400050" y="5505450"/>
+            <a:ext cx="11391900" cy="1047750"/>
+          </a:xfrm>
+          <a:prstGeom xmlns:a="http://schemas.openxmlformats.org/drawingml/2006/main" prst="rect">
+            <a:avLst/>
+          </a:prstGeom>
+          <a:noFill xmlns:a="http://schemas.openxmlformats.org/drawingml/2006/main"/>
+          <a:ln xmlns:a="http://schemas.openxmlformats.org/drawingml/2006/main" w="0">
+            <a:noFill/>
+          </a:ln>
+        </p:spPr>
+        <p:txBody>
+          <a:bodyPr xmlns:a="http://schemas.openxmlformats.org/drawingml/2006/main">
+            <a:noAutofit/>
+          </a:bodyPr>
+          <a:lstStyle xmlns:a="http://schemas.openxmlformats.org/drawingml/2006/main"/>
+          <a:p xmlns:a="http://schemas.openxmlformats.org/drawingml/2006/main">
+            <a:pPr>
+              <a:defRPr sz="1800">
+                <a:solidFill>
+                  <a:srgbClr val="000000"/>
+                </a:solidFill>
+                <a:latin typeface="Arial"/>
+                <a:ea typeface="Arial"/>
+                <a:cs typeface="Arial"/>
+              </a:defRPr>
+            </a:pPr>
+            <a:r>
+              <a:rPr sz="1800">
+                <a:solidFill>
+                  <a:srgbClr val="000000"/>
+                </a:solidFill>
+                <a:latin typeface="Arial"/>
+                <a:ea typeface="Arial"/>
+                <a:cs typeface="Arial"/>
+              </a:rPr>
+              <a:t>Sharing or continuing your work? Credit Keele's SEND team and cite</a:t>
+            </a:r>
+          </a:p>
+          <a:p xmlns:a="http://schemas.openxmlformats.org/drawingml/2006/main">
+            <a:pPr>
+              <a:defRPr sz="1800">
+                <a:solidFill>
+                  <a:srgbClr val="000000"/>
+                </a:solidFill>
+                <a:latin typeface="Arial"/>
+                <a:ea typeface="Arial"/>
+                <a:cs typeface="Arial"/>
+              </a:defRPr>
+            </a:pPr>
+            <a:r>
+              <a:rPr sz="1800">
+                <a:solidFill>
+                  <a:srgbClr val="000000"/>
+                </a:solidFill>
+                <a:latin typeface="Arial"/>
+                <a:ea typeface="Arial"/>
+                <a:cs typeface="Arial"/>
+              </a:rPr>
+              <a:t>the data repository and paper. Describe your own contribution.</a:t>
+            </a:r>
+          </a:p>
+          <a:p xmlns:a="http://schemas.openxmlformats.org/drawingml/2006/main">
+            <a:pPr>
+              <a:defRPr sz="1800">
+                <a:solidFill>
+                  <a:srgbClr val="000000"/>
+                </a:solidFill>
+                <a:latin typeface="Arial"/>
+                <a:ea typeface="Arial"/>
+                <a:cs typeface="Arial"/>
+              </a:defRPr>
+            </a:pPr>
+            <a:r>
+              <a:rPr sz="1800">
+                <a:solidFill>
+                  <a:srgbClr val="000000"/>
+                </a:solidFill>
+                <a:latin typeface="Arial"/>
+                <a:ea typeface="Arial"/>
+                <a:cs typeface="Arial"/>
+              </a:rPr>
+              <a:t>Full citation and example wording: ACKNOWLEDGEMENTS.md</a:t>
             </a:r>
           </a:p>
         </p:txBody>
@@ -4534,254 +4705,5 @@
       </a:bgFillStyleLst>
     </a:fmtScheme>
   </a:themeElements>
-  <a:objectDefaults/>
-  <a:extraClrSchemeLst/>
-</a:theme>
-</file>
-
-<file path=ppt/theme/theme2.xml><?xml version="1.0" encoding="utf-8"?>
-<a:theme xmlns:a="http://schemas.openxmlformats.org/drawingml/2006/main" name="ChatGPT">
-  <a:themeElements>
-    <a:clrScheme name="ChatGPT">
-      <a:dk1>
-        <a:srgbClr val="000000"/>
-      </a:dk1>
-      <a:lt1>
-        <a:srgbClr val="FFFFFF"/>
-      </a:lt1>
-      <a:dk2>
-        <a:srgbClr val="0E2841"/>
-      </a:dk2>
-      <a:lt2>
-        <a:srgbClr val="E8E8E8"/>
-      </a:lt2>
-      <a:accent1>
-        <a:srgbClr val="156082"/>
-      </a:accent1>
-      <a:accent2>
-        <a:srgbClr val="E97132"/>
-      </a:accent2>
-      <a:accent3>
-        <a:srgbClr val="196B24"/>
-      </a:accent3>
-      <a:accent4>
-        <a:srgbClr val="0F9ED5"/>
-      </a:accent4>
-      <a:accent5>
-        <a:srgbClr val="A02B93"/>
-      </a:accent5>
-      <a:accent6>
-        <a:srgbClr val="4EA72E"/>
-      </a:accent6>
-      <a:hlink>
-        <a:srgbClr val="467886"/>
-      </a:hlink>
-      <a:folHlink>
-        <a:srgbClr val="96607D"/>
-      </a:folHlink>
-    </a:clrScheme>
-    <a:fontScheme name="Office">
-      <a:majorFont>
-        <a:latin typeface="Calibri Light"/>
-        <a:ea typeface="Calibri Light"/>
-        <a:cs typeface="Calibri Light"/>
-      </a:majorFont>
-      <a:minorFont>
-        <a:latin typeface="Calibri"/>
-        <a:ea typeface="Calibri"/>
-        <a:cs typeface="Calibri"/>
-      </a:minorFont>
-    </a:fontScheme>
-    <a:fmtScheme name="ChatGPT">
-      <a:fillStyleLst>
-        <a:solidFill>
-          <a:schemeClr val="phClr"/>
-        </a:solidFill>
-        <a:gradFill>
-          <a:gsLst>
-            <a:gs pos="0">
-              <a:schemeClr val="phClr">
-                <a:tint val="67000"/>
-                <a:lumMod val="110000"/>
-                <a:satMod val="105000"/>
-              </a:schemeClr>
-            </a:gs>
-            <a:gs pos="50000">
-              <a:schemeClr val="phClr">
-                <a:tint val="73000"/>
-                <a:lumMod val="105000"/>
-                <a:satMod val="103000"/>
-              </a:schemeClr>
-            </a:gs>
-            <a:gs pos="100000">
-              <a:schemeClr val="phClr">
-                <a:tint val="81000"/>
-                <a:lumMod val="105000"/>
-                <a:satMod val="109000"/>
-              </a:schemeClr>
-            </a:gs>
-          </a:gsLst>
-          <a:lin ang="5400000" scaled="0"/>
-        </a:gradFill>
-        <a:gradFill>
-          <a:gsLst>
-            <a:gs pos="0">
-              <a:schemeClr val="phClr">
-                <a:tint val="94000"/>
-                <a:lumMod val="102000"/>
-                <a:satMod val="103000"/>
-              </a:schemeClr>
-            </a:gs>
-            <a:gs pos="50000">
-              <a:schemeClr val="phClr">
-                <a:shade val="100000"/>
-                <a:lumMod val="100000"/>
-                <a:satMod val="110000"/>
-              </a:schemeClr>
-            </a:gs>
-            <a:gs pos="100000">
-              <a:schemeClr val="phClr">
-                <a:shade val="78000"/>
-                <a:lumMod val="99000"/>
-                <a:satMod val="120000"/>
-              </a:schemeClr>
-            </a:gs>
-          </a:gsLst>
-          <a:lin ang="5400000" scaled="0"/>
-        </a:gradFill>
-      </a:fillStyleLst>
-      <a:lnStyleLst>
-        <a:ln w="12700">
-          <a:solidFill>
-            <a:schemeClr val="phClr"/>
-          </a:solidFill>
-          <a:prstDash val="solid"/>
-        </a:ln>
-        <a:ln w="19050">
-          <a:solidFill>
-            <a:schemeClr val="phClr"/>
-          </a:solidFill>
-          <a:prstDash val="solid"/>
-        </a:ln>
-        <a:ln w="25400">
-          <a:solidFill>
-            <a:schemeClr val="phClr"/>
-          </a:solidFill>
-          <a:prstDash val="solid"/>
-        </a:ln>
-      </a:lnStyleLst>
-      <a:effectStyleLst>
-        <a:effectStyle>
-          <a:effectLst/>
-        </a:effectStyle>
-        <a:effectStyle>
-          <a:effectLst/>
-        </a:effectStyle>
-        <a:effectStyle>
-          <a:effectLst>
-            <a:outerShdw blurRad="57150" dist="19050" dir="5400000">
-              <a:srgbClr val="000000">
-                <a:alpha val="16000"/>
-              </a:srgbClr>
-            </a:outerShdw>
-          </a:effectLst>
-        </a:effectStyle>
-        <a:effectStyle>
-          <a:effectLst>
-            <a:outerShdw blurRad="19050" dist="9525" dir="5400000">
-              <a:srgbClr val="000000">
-                <a:alpha val="6000"/>
-              </a:srgbClr>
-            </a:outerShdw>
-          </a:effectLst>
-        </a:effectStyle>
-        <a:effectStyle>
-          <a:effectLst>
-            <a:outerShdw blurRad="28575" dist="9525" dir="5400000">
-              <a:srgbClr val="000000">
-                <a:alpha val="8000"/>
-              </a:srgbClr>
-            </a:outerShdw>
-          </a:effectLst>
-        </a:effectStyle>
-        <a:effectStyle>
-          <a:effectLst>
-            <a:outerShdw blurRad="57150" dist="19050" dir="5400000">
-              <a:srgbClr val="000000">
-                <a:alpha val="10000"/>
-              </a:srgbClr>
-            </a:outerShdw>
-          </a:effectLst>
-        </a:effectStyle>
-        <a:effectStyle>
-          <a:effectLst>
-            <a:outerShdw blurRad="114300" dist="38100" dir="5400000">
-              <a:srgbClr val="000000">
-                <a:alpha val="12000"/>
-              </a:srgbClr>
-            </a:outerShdw>
-          </a:effectLst>
-        </a:effectStyle>
-        <a:effectStyle>
-          <a:effectLst>
-            <a:outerShdw blurRad="171450" dist="57150" dir="5400000">
-              <a:srgbClr val="000000">
-                <a:alpha val="16000"/>
-              </a:srgbClr>
-            </a:outerShdw>
-          </a:effectLst>
-        </a:effectStyle>
-        <a:effectStyle>
-          <a:effectLst>
-            <a:outerShdw blurRad="266700" dist="95250" dir="5400000">
-              <a:srgbClr val="000000">
-                <a:alpha val="24000"/>
-              </a:srgbClr>
-            </a:outerShdw>
-          </a:effectLst>
-        </a:effectStyle>
-      </a:effectStyleLst>
-      <a:bgFillStyleLst>
-        <a:solidFill>
-          <a:schemeClr val="phClr"/>
-        </a:solidFill>
-        <a:solidFill>
-          <a:schemeClr val="phClr">
-            <a:tint val="95000"/>
-            <a:satMod val="170000"/>
-          </a:schemeClr>
-        </a:solidFill>
-        <a:gradFill>
-          <a:gsLst>
-            <a:gs pos="0">
-              <a:schemeClr val="phClr">
-                <a:tint val="93000"/>
-                <a:shade val="98000"/>
-                <a:lumMod val="102000"/>
-                <a:satMod val="150000"/>
-              </a:schemeClr>
-            </a:gs>
-            <a:gs pos="50000">
-              <a:schemeClr val="phClr">
-                <a:tint val="98000"/>
-                <a:shade val="90000"/>
-                <a:lumMod val="103000"/>
-                <a:satMod val="130000"/>
-              </a:schemeClr>
-            </a:gs>
-            <a:gs pos="100000">
-              <a:schemeClr val="phClr">
-                <a:shade val="63000"/>
-                <a:satMod val="120000"/>
-              </a:schemeClr>
-            </a:gs>
-          </a:gsLst>
-          <a:lin ang="5400000" scaled="0"/>
-        </a:gradFill>
-      </a:bgFillStyleLst>
-    </a:fmtScheme>
-  </a:themeElements>
-  <a:objectDefaults/>
-  <a:extraClrSchemeLst/>
 </a:theme>
 </file>
</xml_diff>

<commit_message>
Add ERA branding to hackathon briefing slides
</commit_message>
<xml_diff>
--- a/slides/ERA-Hackathon-Data-Briefing.pptx
+++ b/slides/ERA-Hackathon-Data-Briefing.pptx
@@ -2,20 +2,20 @@
 <file path=ppt/presentation.xml><?xml version="1.0" encoding="utf-8"?>
 <p:presentation xmlns:p="http://schemas.openxmlformats.org/presentationml/2006/main">
   <p:sldMasterIdLst>
-    <p:sldMasterId xmlns:r="http://schemas.openxmlformats.org/officeDocument/2006/relationships" id="2147483648" r:id="Ra2f211f037b54840"/>
+    <p:sldMasterId xmlns:r="http://schemas.openxmlformats.org/officeDocument/2006/relationships" id="2147483648" r:id="R41b210fb6e6c491a"/>
   </p:sldMasterIdLst>
   <p:notesMasterIdLst>
-    <p:notesMasterId xmlns:r="http://schemas.openxmlformats.org/officeDocument/2006/relationships" r:id="R7ff7a5d711d34605"/>
+    <p:notesMasterId xmlns:r="http://schemas.openxmlformats.org/officeDocument/2006/relationships" r:id="R074fbce400934839"/>
   </p:notesMasterIdLst>
   <p:sldIdLst>
-    <p:sldId xmlns:r="http://schemas.openxmlformats.org/officeDocument/2006/relationships" id="256" r:id="Rcec712fde5ce47de"/>
-    <p:sldId xmlns:r="http://schemas.openxmlformats.org/officeDocument/2006/relationships" id="257" r:id="R261f2376f1414690"/>
-    <p:sldId xmlns:r="http://schemas.openxmlformats.org/officeDocument/2006/relationships" id="258" r:id="R7fdeaa85cfc347ba"/>
-    <p:sldId xmlns:r="http://schemas.openxmlformats.org/officeDocument/2006/relationships" id="259" r:id="R4b36799e3cfc4a5a"/>
-    <p:sldId xmlns:r="http://schemas.openxmlformats.org/officeDocument/2006/relationships" id="260" r:id="R34cbdbbb5eee42fd"/>
-    <p:sldId xmlns:r="http://schemas.openxmlformats.org/officeDocument/2006/relationships" id="261" r:id="R3d51474b15574a0a"/>
-    <p:sldId xmlns:r="http://schemas.openxmlformats.org/officeDocument/2006/relationships" id="262" r:id="R8ea61ce599c14768"/>
-    <p:sldId xmlns:r="http://schemas.openxmlformats.org/officeDocument/2006/relationships" id="263" r:id="R1eb565ca0be440d9"/>
+    <p:sldId xmlns:r="http://schemas.openxmlformats.org/officeDocument/2006/relationships" id="256" r:id="R6f0c9344771049cd"/>
+    <p:sldId xmlns:r="http://schemas.openxmlformats.org/officeDocument/2006/relationships" id="257" r:id="Rade8062613f64c50"/>
+    <p:sldId xmlns:r="http://schemas.openxmlformats.org/officeDocument/2006/relationships" id="258" r:id="R8cdb4152dff94750"/>
+    <p:sldId xmlns:r="http://schemas.openxmlformats.org/officeDocument/2006/relationships" id="259" r:id="Rae2e530a04cc4a92"/>
+    <p:sldId xmlns:r="http://schemas.openxmlformats.org/officeDocument/2006/relationships" id="260" r:id="R004c2183a1794c1c"/>
+    <p:sldId xmlns:r="http://schemas.openxmlformats.org/officeDocument/2006/relationships" id="261" r:id="R4035d9a9a3a94beb"/>
+    <p:sldId xmlns:r="http://schemas.openxmlformats.org/officeDocument/2006/relationships" id="262" r:id="R6accd3809fdf4019"/>
+    <p:sldId xmlns:r="http://schemas.openxmlformats.org/officeDocument/2006/relationships" id="263" r:id="R5cd6e5c24f3b43b1"/>
   </p:sldIdLst>
   <p:sldSz cx="12192000" cy="6858000"/>
   <p:notesSz cx="6858000" cy="9144000"/>
@@ -1123,7 +1123,7 @@
   </p:cSld>
   <p:clrMap bg1="lt1" tx1="dk1" bg2="lt2" tx2="dk2" accent1="accent1" accent2="accent2" accent3="accent3" accent4="accent4" accent5="accent5" accent6="accent6" hlink="hlink" folHlink="folHlink"/>
   <p:sldLayoutIdLst>
-    <p:sldLayoutId xmlns:r="http://schemas.openxmlformats.org/officeDocument/2006/relationships" id="2147483649" r:id="R0ceed60928ec42d7"/>
+    <p:sldLayoutId xmlns:r="http://schemas.openxmlformats.org/officeDocument/2006/relationships" id="2147483649" r:id="R22dbf170966d4ac3"/>
   </p:sldLayoutIdLst>
   <p:txStyles>
     <p:titleStyle>
@@ -1775,7 +1775,7 @@
         </p:nvSpPr>
         <p:spPr>
           <a:xfrm xmlns:a="http://schemas.openxmlformats.org/drawingml/2006/main">
-            <a:off x="400050" y="4762500"/>
+            <a:off x="400050" y="4267200"/>
             <a:ext cx="8096250" cy="514350"/>
           </a:xfrm>
           <a:prstGeom xmlns:a="http://schemas.openxmlformats.org/drawingml/2006/main" prst="rect">
@@ -1821,7 +1821,7 @@
         </p:nvSpPr>
         <p:spPr>
           <a:xfrm xmlns:a="http://schemas.openxmlformats.org/drawingml/2006/main">
-            <a:off x="400050" y="5410200"/>
+            <a:off x="400050" y="4876800"/>
             <a:ext cx="11391900" cy="457200"/>
           </a:xfrm>
           <a:prstGeom xmlns:a="http://schemas.openxmlformats.org/drawingml/2006/main" prst="rect">
@@ -1873,7 +1873,7 @@
         </p:nvSpPr>
         <p:spPr>
           <a:xfrm xmlns:a="http://schemas.openxmlformats.org/drawingml/2006/main">
-            <a:off x="400050" y="5972175"/>
+            <a:off x="400050" y="5400675"/>
             <a:ext cx="11391900" cy="457200"/>
           </a:xfrm>
           <a:prstGeom xmlns:a="http://schemas.openxmlformats.org/drawingml/2006/main" prst="rect">
@@ -1909,6 +1909,113 @@
           </a:p>
         </p:txBody>
       </p:sp>
+      <p:pic>
+        <p:nvPicPr>
+          <p:cNvPr id="16" name=""/>
+          <p:cNvPicPr>
+            <a:picLocks xmlns:a="http://schemas.openxmlformats.org/drawingml/2006/main" noChangeAspect="1"/>
+          </p:cNvPicPr>
+          <p:nvPr/>
+        </p:nvPicPr>
+        <p:blipFill>
+          <a:blip xmlns:r="http://schemas.openxmlformats.org/officeDocument/2006/relationships" xmlns:a="http://schemas.openxmlformats.org/drawingml/2006/main" r:embed="R3d00d0d0c2584b7f"/>
+          <a:stretch xmlns:a="http://schemas.openxmlformats.org/drawingml/2006/main"/>
+        </p:blipFill>
+        <p:spPr>
+          <a:xfrm xmlns:a="http://schemas.openxmlformats.org/drawingml/2006/main">
+            <a:off x="9763125" y="381000"/>
+            <a:ext cx="2000250" cy="353580"/>
+          </a:xfrm>
+          <a:prstGeom xmlns:a="http://schemas.openxmlformats.org/drawingml/2006/main" prst="rect">
+            <a:avLst/>
+          </a:prstGeom>
+        </p:spPr>
+      </p:pic>
+      <p:sp>
+        <p:nvSpPr>
+          <p:cNvPr id="8" name="Partner logo white footer">
+            <a:extLst xmlns:a="http://schemas.openxmlformats.org/drawingml/2006/main">
+              <a:ext uri="{FF2B5EF4-FFF2-40B4-BE49-F238E27FC236}">
+                <a16:creationId xmlns:a16="http://schemas.microsoft.com/office/drawing/2014/main" id="{3663D8B0-FC2D-464B-A880-BEA62F7C3552}"/>
+              </a:ext>
+            </a:extLst>
+          </p:cNvPr>
+          <p:cNvSpPr>
+            <a:spLocks xmlns:a="http://schemas.openxmlformats.org/drawingml/2006/main" noGrp="1"/>
+          </p:cNvSpPr>
+          <p:nvPr/>
+        </p:nvSpPr>
+        <p:spPr>
+          <a:xfrm xmlns:a="http://schemas.openxmlformats.org/drawingml/2006/main">
+            <a:off x="0" y="6000750"/>
+            <a:ext cx="12192000" cy="857250"/>
+          </a:xfrm>
+          <a:prstGeom xmlns:a="http://schemas.openxmlformats.org/drawingml/2006/main" prst="rect">
+            <a:avLst/>
+          </a:prstGeom>
+          <a:solidFill xmlns:a="http://schemas.openxmlformats.org/drawingml/2006/main">
+            <a:srgbClr val="FFFFFF"/>
+          </a:solidFill>
+          <a:ln xmlns:a="http://schemas.openxmlformats.org/drawingml/2006/main" w="0">
+            <a:noFill/>
+          </a:ln>
+        </p:spPr>
+      </p:sp>
+      <p:sp>
+        <p:nvSpPr>
+          <p:cNvPr id="9" name="ERA blue rule">
+            <a:extLst xmlns:a="http://schemas.openxmlformats.org/drawingml/2006/main">
+              <a:ext uri="{FF2B5EF4-FFF2-40B4-BE49-F238E27FC236}">
+                <a16:creationId xmlns:a16="http://schemas.microsoft.com/office/drawing/2014/main" id="{CDE0F962-C3A3-431F-8EA0-E3148647E7E3}"/>
+              </a:ext>
+            </a:extLst>
+          </p:cNvPr>
+          <p:cNvSpPr>
+            <a:spLocks xmlns:a="http://schemas.openxmlformats.org/drawingml/2006/main" noGrp="1"/>
+          </p:cNvSpPr>
+          <p:nvPr/>
+        </p:nvSpPr>
+        <p:spPr>
+          <a:xfrm xmlns:a="http://schemas.openxmlformats.org/drawingml/2006/main">
+            <a:off x="0" y="6000750"/>
+            <a:ext cx="12192000" cy="19050"/>
+          </a:xfrm>
+          <a:prstGeom xmlns:a="http://schemas.openxmlformats.org/drawingml/2006/main" prst="rect">
+            <a:avLst/>
+          </a:prstGeom>
+          <a:solidFill xmlns:a="http://schemas.openxmlformats.org/drawingml/2006/main">
+            <a:srgbClr val="004899"/>
+          </a:solidFill>
+          <a:ln xmlns:a="http://schemas.openxmlformats.org/drawingml/2006/main" w="0">
+            <a:noFill/>
+          </a:ln>
+        </p:spPr>
+      </p:sp>
+      <p:pic>
+        <p:nvPicPr>
+          <p:cNvPr id="19" name=""/>
+          <p:cNvPicPr>
+            <a:picLocks xmlns:a="http://schemas.openxmlformats.org/drawingml/2006/main" noChangeAspect="1"/>
+          </p:cNvPicPr>
+          <p:nvPr/>
+        </p:nvPicPr>
+        <p:blipFill>
+          <a:blip xmlns:r="http://schemas.openxmlformats.org/officeDocument/2006/relationships" xmlns:a="http://schemas.openxmlformats.org/drawingml/2006/main" r:embed="R8c1f052b2ce345fa"/>
+          <a:srcRect xmlns:a="http://schemas.openxmlformats.org/drawingml/2006/main" l="0" t="39598" r="0" b="0"/>
+          <a:stretch xmlns:a="http://schemas.openxmlformats.org/drawingml/2006/main">
+            <a:fillRect l="0" t="0" r="0" b="0"/>
+          </a:stretch>
+        </p:blipFill>
+        <p:spPr>
+          <a:xfrm xmlns:a="http://schemas.openxmlformats.org/drawingml/2006/main">
+            <a:off x="619125" y="6038850"/>
+            <a:ext cx="10953750" cy="811857"/>
+          </a:xfrm>
+          <a:prstGeom xmlns:a="http://schemas.openxmlformats.org/drawingml/2006/main" prst="rect">
+            <a:avLst/>
+          </a:prstGeom>
+        </p:spPr>
+      </p:pic>
     </p:spTree>
     <p:extLst>
       <p:ext uri="{BB962C8B-B14F-4D97-AF65-F5344CB8AC3E}">
@@ -2028,6 +2135,28 @@
           </a:p>
         </p:txBody>
       </p:sp>
+      <p:pic>
+        <p:nvPicPr>
+          <p:cNvPr id="8" name=""/>
+          <p:cNvPicPr>
+            <a:picLocks xmlns:a="http://schemas.openxmlformats.org/drawingml/2006/main" noChangeAspect="1"/>
+          </p:cNvPicPr>
+          <p:nvPr/>
+        </p:nvPicPr>
+        <p:blipFill>
+          <a:blip xmlns:r="http://schemas.openxmlformats.org/officeDocument/2006/relationships" xmlns:a="http://schemas.openxmlformats.org/drawingml/2006/main" r:embed="R8f61a5e0a3714b43"/>
+          <a:stretch xmlns:a="http://schemas.openxmlformats.org/drawingml/2006/main"/>
+        </p:blipFill>
+        <p:spPr>
+          <a:xfrm xmlns:a="http://schemas.openxmlformats.org/drawingml/2006/main">
+            <a:off x="9763125" y="381000"/>
+            <a:ext cx="2000250" cy="353580"/>
+          </a:xfrm>
+          <a:prstGeom xmlns:a="http://schemas.openxmlformats.org/drawingml/2006/main" prst="rect">
+            <a:avLst/>
+          </a:prstGeom>
+        </p:spPr>
+      </p:pic>
     </p:spTree>
     <p:extLst>
       <p:ext uri="{BB962C8B-B14F-4D97-AF65-F5344CB8AC3E}">
@@ -2198,7 +2327,7 @@
       </p:sp>
       <p:graphicFrame>
         <p:nvGraphicFramePr>
-          <p:cNvPr id="11" name="Table 8"/>
+          <p:cNvPr id="12" name="Table 8"/>
           <p:cNvGraphicFramePr/>
           <p:nvPr/>
         </p:nvGraphicFramePr>
@@ -2584,6 +2713,28 @@
           </a:p>
         </p:txBody>
       </p:sp>
+      <p:pic>
+        <p:nvPicPr>
+          <p:cNvPr id="14" name=""/>
+          <p:cNvPicPr>
+            <a:picLocks xmlns:a="http://schemas.openxmlformats.org/drawingml/2006/main" noChangeAspect="1"/>
+          </p:cNvPicPr>
+          <p:nvPr/>
+        </p:nvPicPr>
+        <p:blipFill>
+          <a:blip xmlns:r="http://schemas.openxmlformats.org/officeDocument/2006/relationships" xmlns:a="http://schemas.openxmlformats.org/drawingml/2006/main" r:embed="Ra930f5f3d02b4b90"/>
+          <a:stretch xmlns:a="http://schemas.openxmlformats.org/drawingml/2006/main"/>
+        </p:blipFill>
+        <p:spPr>
+          <a:xfrm xmlns:a="http://schemas.openxmlformats.org/drawingml/2006/main">
+            <a:off x="9763125" y="381000"/>
+            <a:ext cx="2000250" cy="353580"/>
+          </a:xfrm>
+          <a:prstGeom xmlns:a="http://schemas.openxmlformats.org/drawingml/2006/main" prst="rect">
+            <a:avLst/>
+          </a:prstGeom>
+        </p:spPr>
+      </p:pic>
     </p:spTree>
     <p:extLst>
       <p:ext uri="{BB962C8B-B14F-4D97-AF65-F5344CB8AC3E}">
@@ -2754,7 +2905,7 @@
       </p:sp>
       <p:graphicFrame>
         <p:nvGraphicFramePr>
-          <p:cNvPr id="11" name="Table 8"/>
+          <p:cNvPr id="12" name="Table 8"/>
           <p:cNvGraphicFramePr/>
           <p:nvPr/>
         </p:nvGraphicFramePr>
@@ -3140,6 +3291,28 @@
           </a:p>
         </p:txBody>
       </p:sp>
+      <p:pic>
+        <p:nvPicPr>
+          <p:cNvPr id="14" name=""/>
+          <p:cNvPicPr>
+            <a:picLocks xmlns:a="http://schemas.openxmlformats.org/drawingml/2006/main" noChangeAspect="1"/>
+          </p:cNvPicPr>
+          <p:nvPr/>
+        </p:nvPicPr>
+        <p:blipFill>
+          <a:blip xmlns:r="http://schemas.openxmlformats.org/officeDocument/2006/relationships" xmlns:a="http://schemas.openxmlformats.org/drawingml/2006/main" r:embed="R365206543e5c4a55"/>
+          <a:stretch xmlns:a="http://schemas.openxmlformats.org/drawingml/2006/main"/>
+        </p:blipFill>
+        <p:spPr>
+          <a:xfrm xmlns:a="http://schemas.openxmlformats.org/drawingml/2006/main">
+            <a:off x="9763125" y="381000"/>
+            <a:ext cx="2000250" cy="353580"/>
+          </a:xfrm>
+          <a:prstGeom xmlns:a="http://schemas.openxmlformats.org/drawingml/2006/main" prst="rect">
+            <a:avLst/>
+          </a:prstGeom>
+        </p:spPr>
+      </p:pic>
     </p:spTree>
     <p:extLst>
       <p:ext uri="{BB962C8B-B14F-4D97-AF65-F5344CB8AC3E}">
@@ -3263,7 +3436,7 @@
       </p:sp>
       <p:graphicFrame>
         <p:nvGraphicFramePr>
-          <p:cNvPr id="10" name="Table 8"/>
+          <p:cNvPr id="11" name="Table 8"/>
           <p:cNvGraphicFramePr/>
           <p:nvPr/>
         </p:nvGraphicFramePr>
@@ -3503,6 +3676,28 @@
           </a:p>
         </p:txBody>
       </p:sp>
+      <p:pic>
+        <p:nvPicPr>
+          <p:cNvPr id="13" name=""/>
+          <p:cNvPicPr>
+            <a:picLocks xmlns:a="http://schemas.openxmlformats.org/drawingml/2006/main" noChangeAspect="1"/>
+          </p:cNvPicPr>
+          <p:nvPr/>
+        </p:nvPicPr>
+        <p:blipFill>
+          <a:blip xmlns:r="http://schemas.openxmlformats.org/officeDocument/2006/relationships" xmlns:a="http://schemas.openxmlformats.org/drawingml/2006/main" r:embed="R3431611a11344c2c"/>
+          <a:stretch xmlns:a="http://schemas.openxmlformats.org/drawingml/2006/main"/>
+        </p:blipFill>
+        <p:spPr>
+          <a:xfrm xmlns:a="http://schemas.openxmlformats.org/drawingml/2006/main">
+            <a:off x="9763125" y="381000"/>
+            <a:ext cx="2000250" cy="353580"/>
+          </a:xfrm>
+          <a:prstGeom xmlns:a="http://schemas.openxmlformats.org/drawingml/2006/main" prst="rect">
+            <a:avLst/>
+          </a:prstGeom>
+        </p:spPr>
+      </p:pic>
     </p:spTree>
     <p:extLst>
       <p:ext uri="{BB962C8B-B14F-4D97-AF65-F5344CB8AC3E}">
@@ -3626,7 +3821,7 @@
       </p:sp>
       <p:graphicFrame>
         <p:nvGraphicFramePr>
-          <p:cNvPr id="10" name="Table 8"/>
+          <p:cNvPr id="11" name="Table 8"/>
           <p:cNvGraphicFramePr/>
           <p:nvPr/>
         </p:nvGraphicFramePr>
@@ -3866,6 +4061,28 @@
           </a:p>
         </p:txBody>
       </p:sp>
+      <p:pic>
+        <p:nvPicPr>
+          <p:cNvPr id="13" name=""/>
+          <p:cNvPicPr>
+            <a:picLocks xmlns:a="http://schemas.openxmlformats.org/drawingml/2006/main" noChangeAspect="1"/>
+          </p:cNvPicPr>
+          <p:nvPr/>
+        </p:nvPicPr>
+        <p:blipFill>
+          <a:blip xmlns:r="http://schemas.openxmlformats.org/officeDocument/2006/relationships" xmlns:a="http://schemas.openxmlformats.org/drawingml/2006/main" r:embed="R0a303fa526144be5"/>
+          <a:stretch xmlns:a="http://schemas.openxmlformats.org/drawingml/2006/main"/>
+        </p:blipFill>
+        <p:spPr>
+          <a:xfrm xmlns:a="http://schemas.openxmlformats.org/drawingml/2006/main">
+            <a:off x="9763125" y="381000"/>
+            <a:ext cx="2000250" cy="353580"/>
+          </a:xfrm>
+          <a:prstGeom xmlns:a="http://schemas.openxmlformats.org/drawingml/2006/main" prst="rect">
+            <a:avLst/>
+          </a:prstGeom>
+        </p:spPr>
+      </p:pic>
     </p:spTree>
     <p:extLst>
       <p:ext uri="{BB962C8B-B14F-4D97-AF65-F5344CB8AC3E}">
@@ -3989,7 +4206,7 @@
       </p:sp>
       <p:graphicFrame>
         <p:nvGraphicFramePr>
-          <p:cNvPr id="10" name="Table 8"/>
+          <p:cNvPr id="11" name="Table 8"/>
           <p:cNvGraphicFramePr/>
           <p:nvPr/>
         </p:nvGraphicFramePr>
@@ -4229,6 +4446,28 @@
           </a:p>
         </p:txBody>
       </p:sp>
+      <p:pic>
+        <p:nvPicPr>
+          <p:cNvPr id="13" name=""/>
+          <p:cNvPicPr>
+            <a:picLocks xmlns:a="http://schemas.openxmlformats.org/drawingml/2006/main" noChangeAspect="1"/>
+          </p:cNvPicPr>
+          <p:nvPr/>
+        </p:nvPicPr>
+        <p:blipFill>
+          <a:blip xmlns:r="http://schemas.openxmlformats.org/officeDocument/2006/relationships" xmlns:a="http://schemas.openxmlformats.org/drawingml/2006/main" r:embed="R33ecda2196fe4073"/>
+          <a:stretch xmlns:a="http://schemas.openxmlformats.org/drawingml/2006/main"/>
+        </p:blipFill>
+        <p:spPr>
+          <a:xfrm xmlns:a="http://schemas.openxmlformats.org/drawingml/2006/main">
+            <a:off x="9763125" y="381000"/>
+            <a:ext cx="2000250" cy="353580"/>
+          </a:xfrm>
+          <a:prstGeom xmlns:a="http://schemas.openxmlformats.org/drawingml/2006/main" prst="rect">
+            <a:avLst/>
+          </a:prstGeom>
+        </p:spPr>
+      </p:pic>
     </p:spTree>
     <p:extLst>
       <p:ext uri="{BB962C8B-B14F-4D97-AF65-F5344CB8AC3E}">
@@ -4320,8 +4559,8 @@
         </p:nvSpPr>
         <p:spPr>
           <a:xfrm xmlns:a="http://schemas.openxmlformats.org/drawingml/2006/main">
-            <a:off x="400050" y="4762500"/>
-            <a:ext cx="8096250" cy="514350"/>
+            <a:off x="400050" y="4114800"/>
+            <a:ext cx="9525000" cy="514350"/>
           </a:xfrm>
           <a:prstGeom xmlns:a="http://schemas.openxmlformats.org/drawingml/2006/main" prst="rect">
             <a:avLst/>
@@ -4366,7 +4605,7 @@
         </p:nvSpPr>
         <p:spPr>
           <a:xfrm xmlns:a="http://schemas.openxmlformats.org/drawingml/2006/main">
-            <a:off x="400050" y="5505450"/>
+            <a:off x="400050" y="4781550"/>
             <a:ext cx="11391900" cy="1047750"/>
           </a:xfrm>
           <a:prstGeom xmlns:a="http://schemas.openxmlformats.org/drawingml/2006/main" prst="rect">
@@ -4384,6 +4623,7 @@
           <a:lstStyle xmlns:a="http://schemas.openxmlformats.org/drawingml/2006/main"/>
           <a:p xmlns:a="http://schemas.openxmlformats.org/drawingml/2006/main">
             <a:pPr>
+              <a:buNone/>
               <a:defRPr sz="1800">
                 <a:solidFill>
                   <a:srgbClr val="000000"/>
@@ -4407,6 +4647,7 @@
           </a:p>
           <a:p xmlns:a="http://schemas.openxmlformats.org/drawingml/2006/main">
             <a:pPr>
+              <a:buNone/>
               <a:defRPr sz="1800">
                 <a:solidFill>
                   <a:srgbClr val="000000"/>
@@ -4430,6 +4671,7 @@
           </a:p>
           <a:p xmlns:a="http://schemas.openxmlformats.org/drawingml/2006/main">
             <a:pPr>
+              <a:buNone/>
               <a:defRPr sz="1800">
                 <a:solidFill>
                   <a:srgbClr val="000000"/>
@@ -4453,6 +4695,113 @@
           </a:p>
         </p:txBody>
       </p:sp>
+      <p:pic>
+        <p:nvPicPr>
+          <p:cNvPr id="12" name=""/>
+          <p:cNvPicPr>
+            <a:picLocks xmlns:a="http://schemas.openxmlformats.org/drawingml/2006/main" noChangeAspect="1"/>
+          </p:cNvPicPr>
+          <p:nvPr/>
+        </p:nvPicPr>
+        <p:blipFill>
+          <a:blip xmlns:r="http://schemas.openxmlformats.org/officeDocument/2006/relationships" xmlns:a="http://schemas.openxmlformats.org/drawingml/2006/main" r:embed="Ra60ebf68fb1e4c69"/>
+          <a:stretch xmlns:a="http://schemas.openxmlformats.org/drawingml/2006/main"/>
+        </p:blipFill>
+        <p:spPr>
+          <a:xfrm xmlns:a="http://schemas.openxmlformats.org/drawingml/2006/main">
+            <a:off x="9763125" y="381000"/>
+            <a:ext cx="2000250" cy="353580"/>
+          </a:xfrm>
+          <a:prstGeom xmlns:a="http://schemas.openxmlformats.org/drawingml/2006/main" prst="rect">
+            <a:avLst/>
+          </a:prstGeom>
+        </p:spPr>
+      </p:pic>
+      <p:sp>
+        <p:nvSpPr>
+          <p:cNvPr id="6" name="Partner logo white footer">
+            <a:extLst xmlns:a="http://schemas.openxmlformats.org/drawingml/2006/main">
+              <a:ext uri="{FF2B5EF4-FFF2-40B4-BE49-F238E27FC236}">
+                <a16:creationId xmlns:a16="http://schemas.microsoft.com/office/drawing/2014/main" id="{E72FB7BD-3672-4654-9C79-3FD7791C823D}"/>
+              </a:ext>
+            </a:extLst>
+          </p:cNvPr>
+          <p:cNvSpPr>
+            <a:spLocks xmlns:a="http://schemas.openxmlformats.org/drawingml/2006/main" noGrp="1"/>
+          </p:cNvSpPr>
+          <p:nvPr/>
+        </p:nvSpPr>
+        <p:spPr>
+          <a:xfrm xmlns:a="http://schemas.openxmlformats.org/drawingml/2006/main">
+            <a:off x="0" y="6000750"/>
+            <a:ext cx="12192000" cy="857250"/>
+          </a:xfrm>
+          <a:prstGeom xmlns:a="http://schemas.openxmlformats.org/drawingml/2006/main" prst="rect">
+            <a:avLst/>
+          </a:prstGeom>
+          <a:solidFill xmlns:a="http://schemas.openxmlformats.org/drawingml/2006/main">
+            <a:srgbClr val="FFFFFF"/>
+          </a:solidFill>
+          <a:ln xmlns:a="http://schemas.openxmlformats.org/drawingml/2006/main" w="0">
+            <a:noFill/>
+          </a:ln>
+        </p:spPr>
+      </p:sp>
+      <p:sp>
+        <p:nvSpPr>
+          <p:cNvPr id="7" name="ERA blue rule">
+            <a:extLst xmlns:a="http://schemas.openxmlformats.org/drawingml/2006/main">
+              <a:ext uri="{FF2B5EF4-FFF2-40B4-BE49-F238E27FC236}">
+                <a16:creationId xmlns:a16="http://schemas.microsoft.com/office/drawing/2014/main" id="{4EB5639D-3AA1-4CFB-A320-38887F8160A6}"/>
+              </a:ext>
+            </a:extLst>
+          </p:cNvPr>
+          <p:cNvSpPr>
+            <a:spLocks xmlns:a="http://schemas.openxmlformats.org/drawingml/2006/main" noGrp="1"/>
+          </p:cNvSpPr>
+          <p:nvPr/>
+        </p:nvSpPr>
+        <p:spPr>
+          <a:xfrm xmlns:a="http://schemas.openxmlformats.org/drawingml/2006/main">
+            <a:off x="0" y="6000750"/>
+            <a:ext cx="12192000" cy="19050"/>
+          </a:xfrm>
+          <a:prstGeom xmlns:a="http://schemas.openxmlformats.org/drawingml/2006/main" prst="rect">
+            <a:avLst/>
+          </a:prstGeom>
+          <a:solidFill xmlns:a="http://schemas.openxmlformats.org/drawingml/2006/main">
+            <a:srgbClr val="004899"/>
+          </a:solidFill>
+          <a:ln xmlns:a="http://schemas.openxmlformats.org/drawingml/2006/main" w="0">
+            <a:noFill/>
+          </a:ln>
+        </p:spPr>
+      </p:sp>
+      <p:pic>
+        <p:nvPicPr>
+          <p:cNvPr id="15" name=""/>
+          <p:cNvPicPr>
+            <a:picLocks xmlns:a="http://schemas.openxmlformats.org/drawingml/2006/main" noChangeAspect="1"/>
+          </p:cNvPicPr>
+          <p:nvPr/>
+        </p:nvPicPr>
+        <p:blipFill>
+          <a:blip xmlns:r="http://schemas.openxmlformats.org/officeDocument/2006/relationships" xmlns:a="http://schemas.openxmlformats.org/drawingml/2006/main" r:embed="Rae904ace24fc425e"/>
+          <a:srcRect xmlns:a="http://schemas.openxmlformats.org/drawingml/2006/main" l="0" t="39598" r="0" b="0"/>
+          <a:stretch xmlns:a="http://schemas.openxmlformats.org/drawingml/2006/main">
+            <a:fillRect l="0" t="0" r="0" b="0"/>
+          </a:stretch>
+        </p:blipFill>
+        <p:spPr>
+          <a:xfrm xmlns:a="http://schemas.openxmlformats.org/drawingml/2006/main">
+            <a:off x="619125" y="6038850"/>
+            <a:ext cx="10953750" cy="811857"/>
+          </a:xfrm>
+          <a:prstGeom xmlns:a="http://schemas.openxmlformats.org/drawingml/2006/main" prst="rect">
+            <a:avLst/>
+          </a:prstGeom>
+        </p:spPr>
+      </p:pic>
     </p:spTree>
     <p:extLst>
       <p:ext uri="{BB962C8B-B14F-4D97-AF65-F5344CB8AC3E}">

</xml_diff>